<commit_message>
actualizo la actividad 6.3 del tema 6
</commit_message>
<xml_diff>
--- a/Unidades/Tema 6/Actividad 6.3 Banco de Ejercicios_AmauryGordillo_GPTI_7ISCM.pptx
+++ b/Unidades/Tema 6/Actividad 6.3 Banco de Ejercicios_AmauryGordillo_GPTI_7ISCM.pptx
@@ -5,7 +5,7 @@
     <p:sldMasterId id="2147483648" r:id="rId1"/>
   </p:sldMasterIdLst>
   <p:notesMasterIdLst>
-    <p:notesMasterId r:id="rId17"/>
+    <p:notesMasterId r:id="rId18"/>
   </p:notesMasterIdLst>
   <p:sldIdLst>
     <p:sldId id="256" r:id="rId2"/>
@@ -21,8 +21,9 @@
     <p:sldId id="266" r:id="rId12"/>
     <p:sldId id="267" r:id="rId13"/>
     <p:sldId id="268" r:id="rId14"/>
-    <p:sldId id="269" r:id="rId15"/>
-    <p:sldId id="270" r:id="rId16"/>
+    <p:sldId id="271" r:id="rId15"/>
+    <p:sldId id="269" r:id="rId16"/>
+    <p:sldId id="270" r:id="rId17"/>
   </p:sldIdLst>
   <p:sldSz cx="12192000" cy="6858000"/>
   <p:notesSz cx="6858000" cy="9144000"/>
@@ -752,6 +753,11 @@
         </p:txBody>
       </p:sp>
     </p:spTree>
+    <p:extLst>
+      <p:ext uri="{BB962C8B-B14F-4D97-AF65-F5344CB8AC3E}">
+        <p14:creationId xmlns:p14="http://schemas.microsoft.com/office/powerpoint/2010/main" val="826945878"/>
+      </p:ext>
+    </p:extLst>
   </p:cSld>
   <p:clrMapOvr>
     <a:masterClrMapping/>
@@ -760,6 +766,81 @@
 </file>
 
 <file path=ppt/notesSlides/notesSlide15.xml><?xml version="1.0" encoding="utf-8"?>
+<p:notes xmlns:a="http://schemas.openxmlformats.org/drawingml/2006/main" xmlns:r="http://schemas.openxmlformats.org/officeDocument/2006/relationships" xmlns:p="http://schemas.openxmlformats.org/presentationml/2006/main">
+  <p:cSld>
+    <p:spTree>
+      <p:nvGrpSpPr>
+        <p:cNvPr id="1" name=""/>
+        <p:cNvGrpSpPr/>
+        <p:nvPr/>
+      </p:nvGrpSpPr>
+      <p:grpSpPr>
+        <a:xfrm>
+          <a:off x="0" y="0"/>
+          <a:ext cx="0" cy="0"/>
+          <a:chOff x="0" y="0"/>
+          <a:chExt cx="0" cy="0"/>
+        </a:xfrm>
+      </p:grpSpPr>
+      <p:sp>
+        <p:nvSpPr>
+          <p:cNvPr id="2" name="Slide Image Placeholder 1"/>
+          <p:cNvSpPr>
+            <a:spLocks noGrp="1" noRot="1" noChangeAspect="1"/>
+          </p:cNvSpPr>
+          <p:nvPr>
+            <p:ph type="sldImg"/>
+          </p:nvPr>
+        </p:nvSpPr>
+        <p:spPr/>
+      </p:sp>
+      <p:sp>
+        <p:nvSpPr>
+          <p:cNvPr id="3" name="Notes Placeholder 2"/>
+          <p:cNvSpPr>
+            <a:spLocks noGrp="1"/>
+          </p:cNvSpPr>
+          <p:nvPr>
+            <p:ph type="body" idx="1"/>
+          </p:nvPr>
+        </p:nvSpPr>
+        <p:spPr/>
+        <p:txBody>
+          <a:bodyPr/>
+          <a:lstStyle/>
+          <a:p>
+            <a:endParaRPr dirty="0"/>
+          </a:p>
+        </p:txBody>
+      </p:sp>
+      <p:sp>
+        <p:nvSpPr>
+          <p:cNvPr id="4" name="Slide Number Placeholder 3"/>
+          <p:cNvSpPr>
+            <a:spLocks noGrp="1"/>
+          </p:cNvSpPr>
+          <p:nvPr>
+            <p:ph type="sldNum" idx="5"/>
+          </p:nvPr>
+        </p:nvSpPr>
+        <p:spPr/>
+        <p:txBody>
+          <a:bodyPr/>
+          <a:lstStyle/>
+          <a:p>
+            <a:endParaRPr/>
+          </a:p>
+        </p:txBody>
+      </p:sp>
+    </p:spTree>
+  </p:cSld>
+  <p:clrMapOvr>
+    <a:masterClrMapping/>
+  </p:clrMapOvr>
+</p:notes>
+</file>
+
+<file path=ppt/notesSlides/notesSlide16.xml><?xml version="1.0" encoding="utf-8"?>
 <p:notes xmlns:a="http://schemas.openxmlformats.org/drawingml/2006/main" xmlns:r="http://schemas.openxmlformats.org/officeDocument/2006/relationships" xmlns:p="http://schemas.openxmlformats.org/presentationml/2006/main">
   <p:cSld>
     <p:spTree>
@@ -9567,6 +9648,218 @@
 <file path=ppt/slides/slide14.xml><?xml version="1.0" encoding="utf-8"?>
 <p:sld xmlns:a="http://schemas.openxmlformats.org/drawingml/2006/main" xmlns:r="http://schemas.openxmlformats.org/officeDocument/2006/relationships" xmlns:p="http://schemas.openxmlformats.org/presentationml/2006/main">
   <p:cSld>
+    <p:spTree>
+      <p:nvGrpSpPr>
+        <p:cNvPr id="1" name=""/>
+        <p:cNvGrpSpPr/>
+        <p:nvPr/>
+      </p:nvGrpSpPr>
+      <p:grpSpPr>
+        <a:xfrm>
+          <a:off x="0" y="0"/>
+          <a:ext cx="0" cy="0"/>
+          <a:chOff x="0" y="0"/>
+          <a:chExt cx="0" cy="0"/>
+        </a:xfrm>
+      </p:grpSpPr>
+      <p:sp>
+        <p:nvSpPr>
+          <p:cNvPr id="17" name="Rectángulo 16">
+            <a:extLst>
+              <a:ext uri="{FF2B5EF4-FFF2-40B4-BE49-F238E27FC236}">
+                <a16:creationId xmlns:a16="http://schemas.microsoft.com/office/drawing/2014/main" id="{BD45FA68-ED99-4916-8374-E529A2951D14}"/>
+              </a:ext>
+            </a:extLst>
+          </p:cNvPr>
+          <p:cNvSpPr>
+            <a:spLocks noGrp="1"/>
+          </p:cNvSpPr>
+          <p:nvPr/>
+        </p:nvSpPr>
+        <p:spPr>
+          <a:xfrm>
+            <a:off x="666750" y="361950"/>
+            <a:ext cx="10668000" cy="619125"/>
+          </a:xfrm>
+          <a:prstGeom prst="rect">
+            <a:avLst/>
+          </a:prstGeom>
+          <a:ln w="0">
+            <a:noFill/>
+          </a:ln>
+        </p:spPr>
+        <p:txBody>
+          <a:bodyPr anchor="ctr">
+            <a:normAutofit/>
+          </a:bodyPr>
+          <a:lstStyle/>
+          <a:p>
+            <a:pPr algn="l">
+              <a:buNone/>
+              <a:defRPr sz="3150" b="1" i="0">
+                <a:solidFill>
+                  <a:srgbClr val="132338"/>
+                </a:solidFill>
+                <a:latin typeface="Bitstream Charter"/>
+                <a:ea typeface="Bitstream Charter"/>
+                <a:cs typeface="Bitstream Charter"/>
+              </a:defRPr>
+            </a:pPr>
+            <a:r>
+              <a:rPr lang="es-MX" sz="3150" b="1" i="0" dirty="0">
+                <a:solidFill>
+                  <a:srgbClr val="132338"/>
+                </a:solidFill>
+                <a:latin typeface="Bitstream Charter"/>
+                <a:ea typeface="Bitstream Charter"/>
+                <a:cs typeface="Bitstream Charter"/>
+              </a:rPr>
+              <a:t>Link de Git de proyectos Gestionados</a:t>
+            </a:r>
+            <a:endParaRPr sz="3150" b="1" i="0" dirty="0">
+              <a:solidFill>
+                <a:srgbClr val="132338"/>
+              </a:solidFill>
+              <a:latin typeface="Bitstream Charter"/>
+              <a:ea typeface="Bitstream Charter"/>
+              <a:cs typeface="Bitstream Charter"/>
+            </a:endParaRPr>
+          </a:p>
+        </p:txBody>
+      </p:sp>
+      <p:sp>
+        <p:nvSpPr>
+          <p:cNvPr id="2" name="Rectángulo 1">
+            <a:extLst>
+              <a:ext uri="{FF2B5EF4-FFF2-40B4-BE49-F238E27FC236}">
+                <a16:creationId xmlns:a16="http://schemas.microsoft.com/office/drawing/2014/main" id="{F3A2745A-B172-459D-ACE9-ED60B75B8AF7}"/>
+              </a:ext>
+            </a:extLst>
+          </p:cNvPr>
+          <p:cNvSpPr>
+            <a:spLocks noGrp="1"/>
+          </p:cNvSpPr>
+          <p:nvPr/>
+        </p:nvSpPr>
+        <p:spPr>
+          <a:xfrm>
+            <a:off x="666750" y="1123950"/>
+            <a:ext cx="609600" cy="47625"/>
+          </a:xfrm>
+          <a:prstGeom prst="rect">
+            <a:avLst/>
+          </a:prstGeom>
+          <a:solidFill>
+            <a:srgbClr val="4F77A2"/>
+          </a:solidFill>
+          <a:ln w="0">
+            <a:noFill/>
+          </a:ln>
+        </p:spPr>
+      </p:sp>
+      <p:sp>
+        <p:nvSpPr>
+          <p:cNvPr id="4" name="Rectángulo 3">
+            <a:extLst>
+              <a:ext uri="{FF2B5EF4-FFF2-40B4-BE49-F238E27FC236}">
+                <a16:creationId xmlns:a16="http://schemas.microsoft.com/office/drawing/2014/main" id="{85507036-72B3-4641-95E6-FAEF1BF78DA0}"/>
+              </a:ext>
+            </a:extLst>
+          </p:cNvPr>
+          <p:cNvSpPr>
+            <a:spLocks noGrp="1"/>
+          </p:cNvSpPr>
+          <p:nvPr/>
+        </p:nvSpPr>
+        <p:spPr>
+          <a:xfrm>
+            <a:off x="853563" y="1713269"/>
+            <a:ext cx="9647289" cy="1542743"/>
+          </a:xfrm>
+          <a:prstGeom prst="rect">
+            <a:avLst/>
+          </a:prstGeom>
+          <a:ln w="0">
+            <a:noFill/>
+          </a:ln>
+        </p:spPr>
+        <p:txBody>
+          <a:bodyPr anchor="ctr">
+            <a:normAutofit/>
+          </a:bodyPr>
+          <a:lstStyle/>
+          <a:p>
+            <a:pPr algn="l">
+              <a:buNone/>
+              <a:defRPr sz="1425" b="0" i="0">
+                <a:solidFill>
+                  <a:srgbClr val="172A3A"/>
+                </a:solidFill>
+                <a:latin typeface="Bitstream Charter"/>
+                <a:ea typeface="Bitstream Charter"/>
+                <a:cs typeface="Bitstream Charter"/>
+              </a:defRPr>
+            </a:pPr>
+            <a:r>
+              <a:rPr lang="es-MX" sz="1600" b="0" i="0" dirty="0">
+                <a:solidFill>
+                  <a:srgbClr val="172A3A"/>
+                </a:solidFill>
+                <a:latin typeface="Bitstream Charter"/>
+                <a:ea typeface="Bitstream Charter"/>
+                <a:cs typeface="Bitstream Charter"/>
+                <a:hlinkClick r:id="rId3"/>
+              </a:rPr>
+              <a:t>https://github.com/amaurycolochos-cpu/Gesti-n-de-proyectos-de-TI/tree/main/Proyectos</a:t>
+            </a:r>
+            <a:endParaRPr lang="es-MX" sz="1600" b="0" i="0" dirty="0">
+              <a:solidFill>
+                <a:srgbClr val="172A3A"/>
+              </a:solidFill>
+              <a:latin typeface="Bitstream Charter"/>
+              <a:ea typeface="Bitstream Charter"/>
+              <a:cs typeface="Bitstream Charter"/>
+            </a:endParaRPr>
+          </a:p>
+          <a:p>
+            <a:pPr algn="l">
+              <a:buNone/>
+              <a:defRPr sz="1425" b="0" i="0">
+                <a:solidFill>
+                  <a:srgbClr val="172A3A"/>
+                </a:solidFill>
+                <a:latin typeface="Bitstream Charter"/>
+                <a:ea typeface="Bitstream Charter"/>
+                <a:cs typeface="Bitstream Charter"/>
+              </a:defRPr>
+            </a:pPr>
+            <a:endParaRPr sz="1600" b="0" i="0" dirty="0">
+              <a:solidFill>
+                <a:srgbClr val="172A3A"/>
+              </a:solidFill>
+              <a:latin typeface="Bitstream Charter"/>
+              <a:ea typeface="Bitstream Charter"/>
+              <a:cs typeface="Bitstream Charter"/>
+            </a:endParaRPr>
+          </a:p>
+        </p:txBody>
+      </p:sp>
+    </p:spTree>
+    <p:extLst>
+      <p:ext uri="{BB962C8B-B14F-4D97-AF65-F5344CB8AC3E}">
+        <p14:creationId xmlns:p14="http://schemas.microsoft.com/office/powerpoint/2010/main" val="2584780316"/>
+      </p:ext>
+    </p:extLst>
+  </p:cSld>
+  <p:clrMapOvr>
+    <a:masterClrMapping/>
+  </p:clrMapOvr>
+</p:sld>
+</file>
+
+<file path=ppt/slides/slide15.xml><?xml version="1.0" encoding="utf-8"?>
+<p:sld xmlns:a="http://schemas.openxmlformats.org/drawingml/2006/main" xmlns:r="http://schemas.openxmlformats.org/officeDocument/2006/relationships" xmlns:p="http://schemas.openxmlformats.org/presentationml/2006/main">
+  <p:cSld>
     <p:bg>
       <p:bgPr>
         <a:solidFill>
@@ -9803,7 +10096,7 @@
 </p:sld>
 </file>
 
-<file path=ppt/slides/slide15.xml><?xml version="1.0" encoding="utf-8"?>
+<file path=ppt/slides/slide16.xml><?xml version="1.0" encoding="utf-8"?>
 <p:sld xmlns:a="http://schemas.openxmlformats.org/drawingml/2006/main" xmlns:r="http://schemas.openxmlformats.org/officeDocument/2006/relationships" xmlns:p="http://schemas.openxmlformats.org/presentationml/2006/main">
   <p:cSld>
     <p:bg>

</xml_diff>

<commit_message>
corrijo la actividad 6.3 del tema 6 con la version completa de 16 diapositivas
</commit_message>
<xml_diff>
--- a/Unidades/Tema 6/Actividad 6.3 Banco de Ejercicios_AmauryGordillo_GPTI_7ISCM.pptx
+++ b/Unidades/Tema 6/Actividad 6.3 Banco de Ejercicios_AmauryGordillo_GPTI_7ISCM.pptx
@@ -5,7 +5,7 @@
     <p:sldMasterId id="2147483648" r:id="rId1"/>
   </p:sldMasterIdLst>
   <p:notesMasterIdLst>
-    <p:notesMasterId r:id="rId17"/>
+    <p:notesMasterId r:id="rId18"/>
   </p:notesMasterIdLst>
   <p:sldIdLst>
     <p:sldId id="256" r:id="rId2"/>
@@ -21,8 +21,9 @@
     <p:sldId id="266" r:id="rId12"/>
     <p:sldId id="267" r:id="rId13"/>
     <p:sldId id="268" r:id="rId14"/>
-    <p:sldId id="269" r:id="rId15"/>
-    <p:sldId id="270" r:id="rId16"/>
+    <p:sldId id="271" r:id="rId15"/>
+    <p:sldId id="269" r:id="rId16"/>
+    <p:sldId id="270" r:id="rId17"/>
   </p:sldIdLst>
   <p:sldSz cx="12192000" cy="6858000"/>
   <p:notesSz cx="6858000" cy="9144000"/>
@@ -752,6 +753,11 @@
         </p:txBody>
       </p:sp>
     </p:spTree>
+    <p:extLst>
+      <p:ext uri="{BB962C8B-B14F-4D97-AF65-F5344CB8AC3E}">
+        <p14:creationId xmlns:p14="http://schemas.microsoft.com/office/powerpoint/2010/main" val="826945878"/>
+      </p:ext>
+    </p:extLst>
   </p:cSld>
   <p:clrMapOvr>
     <a:masterClrMapping/>
@@ -760,6 +766,81 @@
 </file>
 
 <file path=ppt/notesSlides/notesSlide15.xml><?xml version="1.0" encoding="utf-8"?>
+<p:notes xmlns:a="http://schemas.openxmlformats.org/drawingml/2006/main" xmlns:r="http://schemas.openxmlformats.org/officeDocument/2006/relationships" xmlns:p="http://schemas.openxmlformats.org/presentationml/2006/main">
+  <p:cSld>
+    <p:spTree>
+      <p:nvGrpSpPr>
+        <p:cNvPr id="1" name=""/>
+        <p:cNvGrpSpPr/>
+        <p:nvPr/>
+      </p:nvGrpSpPr>
+      <p:grpSpPr>
+        <a:xfrm>
+          <a:off x="0" y="0"/>
+          <a:ext cx="0" cy="0"/>
+          <a:chOff x="0" y="0"/>
+          <a:chExt cx="0" cy="0"/>
+        </a:xfrm>
+      </p:grpSpPr>
+      <p:sp>
+        <p:nvSpPr>
+          <p:cNvPr id="2" name="Slide Image Placeholder 1"/>
+          <p:cNvSpPr>
+            <a:spLocks noGrp="1" noRot="1" noChangeAspect="1"/>
+          </p:cNvSpPr>
+          <p:nvPr>
+            <p:ph type="sldImg"/>
+          </p:nvPr>
+        </p:nvSpPr>
+        <p:spPr/>
+      </p:sp>
+      <p:sp>
+        <p:nvSpPr>
+          <p:cNvPr id="3" name="Notes Placeholder 2"/>
+          <p:cNvSpPr>
+            <a:spLocks noGrp="1"/>
+          </p:cNvSpPr>
+          <p:nvPr>
+            <p:ph type="body" idx="1"/>
+          </p:nvPr>
+        </p:nvSpPr>
+        <p:spPr/>
+        <p:txBody>
+          <a:bodyPr/>
+          <a:lstStyle/>
+          <a:p>
+            <a:endParaRPr dirty="0"/>
+          </a:p>
+        </p:txBody>
+      </p:sp>
+      <p:sp>
+        <p:nvSpPr>
+          <p:cNvPr id="4" name="Slide Number Placeholder 3"/>
+          <p:cNvSpPr>
+            <a:spLocks noGrp="1"/>
+          </p:cNvSpPr>
+          <p:nvPr>
+            <p:ph type="sldNum" idx="5"/>
+          </p:nvPr>
+        </p:nvSpPr>
+        <p:spPr/>
+        <p:txBody>
+          <a:bodyPr/>
+          <a:lstStyle/>
+          <a:p>
+            <a:endParaRPr/>
+          </a:p>
+        </p:txBody>
+      </p:sp>
+    </p:spTree>
+  </p:cSld>
+  <p:clrMapOvr>
+    <a:masterClrMapping/>
+  </p:clrMapOvr>
+</p:notes>
+</file>
+
+<file path=ppt/notesSlides/notesSlide16.xml><?xml version="1.0" encoding="utf-8"?>
 <p:notes xmlns:a="http://schemas.openxmlformats.org/drawingml/2006/main" xmlns:r="http://schemas.openxmlformats.org/officeDocument/2006/relationships" xmlns:p="http://schemas.openxmlformats.org/presentationml/2006/main">
   <p:cSld>
     <p:spTree>
@@ -9567,6 +9648,218 @@
 <file path=ppt/slides/slide14.xml><?xml version="1.0" encoding="utf-8"?>
 <p:sld xmlns:a="http://schemas.openxmlformats.org/drawingml/2006/main" xmlns:r="http://schemas.openxmlformats.org/officeDocument/2006/relationships" xmlns:p="http://schemas.openxmlformats.org/presentationml/2006/main">
   <p:cSld>
+    <p:spTree>
+      <p:nvGrpSpPr>
+        <p:cNvPr id="1" name=""/>
+        <p:cNvGrpSpPr/>
+        <p:nvPr/>
+      </p:nvGrpSpPr>
+      <p:grpSpPr>
+        <a:xfrm>
+          <a:off x="0" y="0"/>
+          <a:ext cx="0" cy="0"/>
+          <a:chOff x="0" y="0"/>
+          <a:chExt cx="0" cy="0"/>
+        </a:xfrm>
+      </p:grpSpPr>
+      <p:sp>
+        <p:nvSpPr>
+          <p:cNvPr id="17" name="Rectángulo 16">
+            <a:extLst>
+              <a:ext uri="{FF2B5EF4-FFF2-40B4-BE49-F238E27FC236}">
+                <a16:creationId xmlns:a16="http://schemas.microsoft.com/office/drawing/2014/main" id="{BD45FA68-ED99-4916-8374-E529A2951D14}"/>
+              </a:ext>
+            </a:extLst>
+          </p:cNvPr>
+          <p:cNvSpPr>
+            <a:spLocks noGrp="1"/>
+          </p:cNvSpPr>
+          <p:nvPr/>
+        </p:nvSpPr>
+        <p:spPr>
+          <a:xfrm>
+            <a:off x="666750" y="361950"/>
+            <a:ext cx="10668000" cy="619125"/>
+          </a:xfrm>
+          <a:prstGeom prst="rect">
+            <a:avLst/>
+          </a:prstGeom>
+          <a:ln w="0">
+            <a:noFill/>
+          </a:ln>
+        </p:spPr>
+        <p:txBody>
+          <a:bodyPr anchor="ctr">
+            <a:normAutofit/>
+          </a:bodyPr>
+          <a:lstStyle/>
+          <a:p>
+            <a:pPr algn="l">
+              <a:buNone/>
+              <a:defRPr sz="3150" b="1" i="0">
+                <a:solidFill>
+                  <a:srgbClr val="132338"/>
+                </a:solidFill>
+                <a:latin typeface="Bitstream Charter"/>
+                <a:ea typeface="Bitstream Charter"/>
+                <a:cs typeface="Bitstream Charter"/>
+              </a:defRPr>
+            </a:pPr>
+            <a:r>
+              <a:rPr lang="es-MX" sz="3150" b="1" i="0" dirty="0">
+                <a:solidFill>
+                  <a:srgbClr val="132338"/>
+                </a:solidFill>
+                <a:latin typeface="Bitstream Charter"/>
+                <a:ea typeface="Bitstream Charter"/>
+                <a:cs typeface="Bitstream Charter"/>
+              </a:rPr>
+              <a:t>Link de Git de proyectos Gestionados</a:t>
+            </a:r>
+            <a:endParaRPr sz="3150" b="1" i="0" dirty="0">
+              <a:solidFill>
+                <a:srgbClr val="132338"/>
+              </a:solidFill>
+              <a:latin typeface="Bitstream Charter"/>
+              <a:ea typeface="Bitstream Charter"/>
+              <a:cs typeface="Bitstream Charter"/>
+            </a:endParaRPr>
+          </a:p>
+        </p:txBody>
+      </p:sp>
+      <p:sp>
+        <p:nvSpPr>
+          <p:cNvPr id="2" name="Rectángulo 1">
+            <a:extLst>
+              <a:ext uri="{FF2B5EF4-FFF2-40B4-BE49-F238E27FC236}">
+                <a16:creationId xmlns:a16="http://schemas.microsoft.com/office/drawing/2014/main" id="{F3A2745A-B172-459D-ACE9-ED60B75B8AF7}"/>
+              </a:ext>
+            </a:extLst>
+          </p:cNvPr>
+          <p:cNvSpPr>
+            <a:spLocks noGrp="1"/>
+          </p:cNvSpPr>
+          <p:nvPr/>
+        </p:nvSpPr>
+        <p:spPr>
+          <a:xfrm>
+            <a:off x="666750" y="1123950"/>
+            <a:ext cx="609600" cy="47625"/>
+          </a:xfrm>
+          <a:prstGeom prst="rect">
+            <a:avLst/>
+          </a:prstGeom>
+          <a:solidFill>
+            <a:srgbClr val="4F77A2"/>
+          </a:solidFill>
+          <a:ln w="0">
+            <a:noFill/>
+          </a:ln>
+        </p:spPr>
+      </p:sp>
+      <p:sp>
+        <p:nvSpPr>
+          <p:cNvPr id="4" name="Rectángulo 3">
+            <a:extLst>
+              <a:ext uri="{FF2B5EF4-FFF2-40B4-BE49-F238E27FC236}">
+                <a16:creationId xmlns:a16="http://schemas.microsoft.com/office/drawing/2014/main" id="{85507036-72B3-4641-95E6-FAEF1BF78DA0}"/>
+              </a:ext>
+            </a:extLst>
+          </p:cNvPr>
+          <p:cNvSpPr>
+            <a:spLocks noGrp="1"/>
+          </p:cNvSpPr>
+          <p:nvPr/>
+        </p:nvSpPr>
+        <p:spPr>
+          <a:xfrm>
+            <a:off x="853563" y="1713269"/>
+            <a:ext cx="9647289" cy="1542743"/>
+          </a:xfrm>
+          <a:prstGeom prst="rect">
+            <a:avLst/>
+          </a:prstGeom>
+          <a:ln w="0">
+            <a:noFill/>
+          </a:ln>
+        </p:spPr>
+        <p:txBody>
+          <a:bodyPr anchor="ctr">
+            <a:normAutofit/>
+          </a:bodyPr>
+          <a:lstStyle/>
+          <a:p>
+            <a:pPr algn="l">
+              <a:buNone/>
+              <a:defRPr sz="1425" b="0" i="0">
+                <a:solidFill>
+                  <a:srgbClr val="172A3A"/>
+                </a:solidFill>
+                <a:latin typeface="Bitstream Charter"/>
+                <a:ea typeface="Bitstream Charter"/>
+                <a:cs typeface="Bitstream Charter"/>
+              </a:defRPr>
+            </a:pPr>
+            <a:r>
+              <a:rPr lang="es-MX" sz="1600" b="0" i="0" dirty="0">
+                <a:solidFill>
+                  <a:srgbClr val="172A3A"/>
+                </a:solidFill>
+                <a:latin typeface="Bitstream Charter"/>
+                <a:ea typeface="Bitstream Charter"/>
+                <a:cs typeface="Bitstream Charter"/>
+                <a:hlinkClick r:id="rId3"/>
+              </a:rPr>
+              <a:t>https://github.com/amaurycolochos-cpu/Gesti-n-de-proyectos-de-TI/tree/main/Proyectos</a:t>
+            </a:r>
+            <a:endParaRPr lang="es-MX" sz="1600" b="0" i="0" dirty="0">
+              <a:solidFill>
+                <a:srgbClr val="172A3A"/>
+              </a:solidFill>
+              <a:latin typeface="Bitstream Charter"/>
+              <a:ea typeface="Bitstream Charter"/>
+              <a:cs typeface="Bitstream Charter"/>
+            </a:endParaRPr>
+          </a:p>
+          <a:p>
+            <a:pPr algn="l">
+              <a:buNone/>
+              <a:defRPr sz="1425" b="0" i="0">
+                <a:solidFill>
+                  <a:srgbClr val="172A3A"/>
+                </a:solidFill>
+                <a:latin typeface="Bitstream Charter"/>
+                <a:ea typeface="Bitstream Charter"/>
+                <a:cs typeface="Bitstream Charter"/>
+              </a:defRPr>
+            </a:pPr>
+            <a:endParaRPr sz="1600" b="0" i="0" dirty="0">
+              <a:solidFill>
+                <a:srgbClr val="172A3A"/>
+              </a:solidFill>
+              <a:latin typeface="Bitstream Charter"/>
+              <a:ea typeface="Bitstream Charter"/>
+              <a:cs typeface="Bitstream Charter"/>
+            </a:endParaRPr>
+          </a:p>
+        </p:txBody>
+      </p:sp>
+    </p:spTree>
+    <p:extLst>
+      <p:ext uri="{BB962C8B-B14F-4D97-AF65-F5344CB8AC3E}">
+        <p14:creationId xmlns:p14="http://schemas.microsoft.com/office/powerpoint/2010/main" val="2584780316"/>
+      </p:ext>
+    </p:extLst>
+  </p:cSld>
+  <p:clrMapOvr>
+    <a:masterClrMapping/>
+  </p:clrMapOvr>
+</p:sld>
+</file>
+
+<file path=ppt/slides/slide15.xml><?xml version="1.0" encoding="utf-8"?>
+<p:sld xmlns:a="http://schemas.openxmlformats.org/drawingml/2006/main" xmlns:r="http://schemas.openxmlformats.org/officeDocument/2006/relationships" xmlns:p="http://schemas.openxmlformats.org/presentationml/2006/main">
+  <p:cSld>
     <p:bg>
       <p:bgPr>
         <a:solidFill>
@@ -9803,7 +10096,7 @@
 </p:sld>
 </file>
 
-<file path=ppt/slides/slide15.xml><?xml version="1.0" encoding="utf-8"?>
+<file path=ppt/slides/slide16.xml><?xml version="1.0" encoding="utf-8"?>
 <p:sld xmlns:a="http://schemas.openxmlformats.org/drawingml/2006/main" xmlns:r="http://schemas.openxmlformats.org/officeDocument/2006/relationships" xmlns:p="http://schemas.openxmlformats.org/presentationml/2006/main">
   <p:cSld>
     <p:bg>

</xml_diff>